<commit_message>
fix(deck-template): swap pptxgenjs stock Office theme for Kilowott brand fonts
pptxgenjs ships with PowerPoint's default Office theme, which embeds
Calibri Light (major) + Calibri (minor) as theme fonts. Even though
every text run in the 15 slides explicitly overrides with Newsreader /
DM Sans / JetBrains Mono, the font menu and any new text box created by
the user (or by Google Slides' import) defaulted to Calibri — off-brand.

Fix: post-process the .pptx after pptxgenjs writes, rewriting
ppt/theme/theme1.xml so:
- a:majorFont latin typeface → "Newsreader" (was "Calibri Light")
- a:minorFont latin typeface → "DM Sans"  (was "Calibri")
- theme + fontScheme name → "Kilowott"

Script-specific fallback fonts (CJK, Arabic, Hebrew, etc.) kept intact
so multilingual text still renders. Verified: pptx is still valid, all
15 slides intact, 1920×1080 canvas, text runs still reference the right
families.

Co-Authored-By: Claude Opus 4.7 (1M context) <noreply@anthropic.com>
</commit_message>
<xml_diff>
--- a/project/downloads/kilowott-deck-template.pptx
+++ b/project/downloads/kilowott-deck-template.pptx
@@ -13525,7 +13525,7 @@
 </file>
 
 <file path=ppt/theme/theme1.xml><?xml version="1.0" encoding="utf-8"?>
-<a:theme xmlns:a="http://schemas.openxmlformats.org/drawingml/2006/main" name="Office Theme">
+<a:theme xmlns:a="http://schemas.openxmlformats.org/drawingml/2006/main" name="Kilowott">
   <a:themeElements>
     <a:clrScheme name="Office">
       <a:dk1>
@@ -13565,9 +13565,9 @@
         <a:srgbClr val="954F72"/>
       </a:folHlink>
     </a:clrScheme>
-    <a:fontScheme name="Office">
+    <a:fontScheme name="Kilowott">
       <a:majorFont>
-        <a:latin typeface="Calibri Light" panose="020F0302020204030204"/>
+        <a:latin typeface="Newsreader"/>
         <a:ea typeface=""/>
         <a:cs typeface=""/>
         <a:font script="Jpan" typeface="游ゴシック Light"/>
@@ -13619,7 +13619,7 @@
         <a:font script="Tfng" typeface="Ebrima"/>
       </a:majorFont>
       <a:minorFont>
-        <a:latin typeface="Calibri" panose="020F0502020204030204"/>
+        <a:latin typeface="DM Sans"/>
         <a:ea typeface=""/>
         <a:cs typeface=""/>
         <a:font script="Jpan" typeface="游ゴシック"/>

</xml_diff>